<commit_message>
Updated slides for S26 crash course
</commit_message>
<xml_diff>
--- a/crash-course/hr_diagram_background.pptx
+++ b/crash-course/hr_diagram_background.pptx
@@ -213,7 +213,7 @@
           <a:p>
             <a:fld id="{39C24956-DDFA-3D48-8EA5-3D83A7234E0D}" type="datetimeFigureOut">
               <a:rPr lang="en-US" smtClean="0"/>
-              <a:t>9/17/25</a:t>
+              <a:t>2/18/26</a:t>
             </a:fld>
             <a:endParaRPr lang="en-US"/>
           </a:p>
@@ -1685,7 +1685,7 @@
           <a:p>
             <a:fld id="{7FF84FA7-896A-814F-9A97-BE696766DBBC}" type="datetimeFigureOut">
               <a:rPr lang="en-US" smtClean="0"/>
-              <a:t>9/17/25</a:t>
+              <a:t>2/18/26</a:t>
             </a:fld>
             <a:endParaRPr lang="en-US"/>
           </a:p>
@@ -1883,7 +1883,7 @@
           <a:p>
             <a:fld id="{7FF84FA7-896A-814F-9A97-BE696766DBBC}" type="datetimeFigureOut">
               <a:rPr lang="en-US" smtClean="0"/>
-              <a:t>9/17/25</a:t>
+              <a:t>2/18/26</a:t>
             </a:fld>
             <a:endParaRPr lang="en-US"/>
           </a:p>
@@ -2091,7 +2091,7 @@
           <a:p>
             <a:fld id="{7FF84FA7-896A-814F-9A97-BE696766DBBC}" type="datetimeFigureOut">
               <a:rPr lang="en-US" smtClean="0"/>
-              <a:t>9/17/25</a:t>
+              <a:t>2/18/26</a:t>
             </a:fld>
             <a:endParaRPr lang="en-US"/>
           </a:p>
@@ -2289,7 +2289,7 @@
           <a:p>
             <a:fld id="{7FF84FA7-896A-814F-9A97-BE696766DBBC}" type="datetimeFigureOut">
               <a:rPr lang="en-US" smtClean="0"/>
-              <a:t>9/17/25</a:t>
+              <a:t>2/18/26</a:t>
             </a:fld>
             <a:endParaRPr lang="en-US"/>
           </a:p>
@@ -2564,7 +2564,7 @@
           <a:p>
             <a:fld id="{7FF84FA7-896A-814F-9A97-BE696766DBBC}" type="datetimeFigureOut">
               <a:rPr lang="en-US" smtClean="0"/>
-              <a:t>9/17/25</a:t>
+              <a:t>2/18/26</a:t>
             </a:fld>
             <a:endParaRPr lang="en-US"/>
           </a:p>
@@ -2829,7 +2829,7 @@
           <a:p>
             <a:fld id="{7FF84FA7-896A-814F-9A97-BE696766DBBC}" type="datetimeFigureOut">
               <a:rPr lang="en-US" smtClean="0"/>
-              <a:t>9/17/25</a:t>
+              <a:t>2/18/26</a:t>
             </a:fld>
             <a:endParaRPr lang="en-US"/>
           </a:p>
@@ -3241,7 +3241,7 @@
           <a:p>
             <a:fld id="{7FF84FA7-896A-814F-9A97-BE696766DBBC}" type="datetimeFigureOut">
               <a:rPr lang="en-US" smtClean="0"/>
-              <a:t>9/17/25</a:t>
+              <a:t>2/18/26</a:t>
             </a:fld>
             <a:endParaRPr lang="en-US"/>
           </a:p>
@@ -3382,7 +3382,7 @@
           <a:p>
             <a:fld id="{7FF84FA7-896A-814F-9A97-BE696766DBBC}" type="datetimeFigureOut">
               <a:rPr lang="en-US" smtClean="0"/>
-              <a:t>9/17/25</a:t>
+              <a:t>2/18/26</a:t>
             </a:fld>
             <a:endParaRPr lang="en-US"/>
           </a:p>
@@ -3495,7 +3495,7 @@
           <a:p>
             <a:fld id="{7FF84FA7-896A-814F-9A97-BE696766DBBC}" type="datetimeFigureOut">
               <a:rPr lang="en-US" smtClean="0"/>
-              <a:t>9/17/25</a:t>
+              <a:t>2/18/26</a:t>
             </a:fld>
             <a:endParaRPr lang="en-US"/>
           </a:p>
@@ -3806,7 +3806,7 @@
           <a:p>
             <a:fld id="{7FF84FA7-896A-814F-9A97-BE696766DBBC}" type="datetimeFigureOut">
               <a:rPr lang="en-US" smtClean="0"/>
-              <a:t>9/17/25</a:t>
+              <a:t>2/18/26</a:t>
             </a:fld>
             <a:endParaRPr lang="en-US"/>
           </a:p>
@@ -4094,7 +4094,7 @@
           <a:p>
             <a:fld id="{7FF84FA7-896A-814F-9A97-BE696766DBBC}" type="datetimeFigureOut">
               <a:rPr lang="en-US" smtClean="0"/>
-              <a:t>9/17/25</a:t>
+              <a:t>2/18/26</a:t>
             </a:fld>
             <a:endParaRPr lang="en-US"/>
           </a:p>
@@ -4335,7 +4335,7 @@
           <a:p>
             <a:fld id="{7FF84FA7-896A-814F-9A97-BE696766DBBC}" type="datetimeFigureOut">
               <a:rPr lang="en-US" smtClean="0"/>
-              <a:t>9/17/25</a:t>
+              <a:t>2/18/26</a:t>
             </a:fld>
             <a:endParaRPr lang="en-US"/>
           </a:p>
@@ -4815,7 +4815,7 @@
           <a:p>
             <a:r>
               <a:rPr lang="en-US" dirty="0"/>
-              <a:t>September 17, 2025</a:t>
+              <a:t>February 18, 2026</a:t>
             </a:r>
           </a:p>
         </p:txBody>
@@ -5229,8 +5229,8 @@
           </a:p>
         </p:txBody>
       </p:sp>
-      <mc:AlternateContent xmlns:mc="http://schemas.openxmlformats.org/markup-compatibility/2006">
-        <mc:Choice xmlns:a14="http://schemas.microsoft.com/office/drawing/2010/main" Requires="a14">
+      <mc:AlternateContent xmlns:mc="http://schemas.openxmlformats.org/markup-compatibility/2006" xmlns:a14="http://schemas.microsoft.com/office/drawing/2010/main">
+        <mc:Choice Requires="a14">
           <p:sp>
             <p:nvSpPr>
               <p:cNvPr id="3" name="Content Placeholder 2">
@@ -5439,7 +5439,7 @@
             </p:txBody>
           </p:sp>
         </mc:Choice>
-        <mc:Fallback>
+        <mc:Fallback xmlns="">
           <p:sp>
             <p:nvSpPr>
               <p:cNvPr id="3" name="Content Placeholder 2">
@@ -5537,8 +5537,8 @@
           </a:p>
         </p:txBody>
       </p:sp>
-      <mc:AlternateContent xmlns:mc="http://schemas.openxmlformats.org/markup-compatibility/2006">
-        <mc:Choice xmlns:a14="http://schemas.microsoft.com/office/drawing/2010/main" Requires="a14">
+      <mc:AlternateContent xmlns:mc="http://schemas.openxmlformats.org/markup-compatibility/2006" xmlns:a14="http://schemas.microsoft.com/office/drawing/2010/main">
+        <mc:Choice Requires="a14">
           <p:sp>
             <p:nvSpPr>
               <p:cNvPr id="3" name="Content Placeholder 2">
@@ -5632,7 +5632,7 @@
             </p:txBody>
           </p:sp>
         </mc:Choice>
-        <mc:Fallback>
+        <mc:Fallback xmlns="">
           <p:sp>
             <p:nvSpPr>
               <p:cNvPr id="3" name="Content Placeholder 2">

</xml_diff>